<commit_message>
docs: update internal content Vortex → Traverse, VTX → TRV
</commit_message>
<xml_diff>
--- a/Traverse_PitchDeck.pptx
+++ b/Traverse_PitchDeck.pptx
@@ -2921,6 +2921,10 @@
             <a:prstDash val="solid"/>
           </a:ln>
         </p:spPr>
+        <p:txBody>
+          <a:bodyPr/>
+          <a:p/>
+        </p:txBody>
       </p:sp>
       <p:sp>
         <p:nvSpPr>
@@ -2948,6 +2952,10 @@
             <a:prstDash val="solid"/>
           </a:ln>
         </p:spPr>
+        <p:txBody>
+          <a:bodyPr/>
+          <a:p/>
+        </p:txBody>
       </p:sp>
       <p:sp>
         <p:nvSpPr>
@@ -2975,6 +2983,10 @@
             <a:prstDash val="solid"/>
           </a:ln>
         </p:spPr>
+        <p:txBody>
+          <a:bodyPr/>
+          <a:p/>
+        </p:txBody>
       </p:sp>
       <p:sp>
         <p:nvSpPr>
@@ -3009,7 +3021,7 @@
                 <a:ea typeface="Georgia" pitchFamily="34" charset="-122"/>
                 <a:cs typeface="Georgia" pitchFamily="34" charset="-120"/>
               </a:rPr>
-              <a:t>VORTEX</a:t>
+              <a:t>TRAVERSE</a:t>
             </a:r>
             <a:endParaRPr lang="en-US" sz="6400" dirty="0"/>
           </a:p>
@@ -3087,7 +3099,7 @@
                 <a:ea typeface="Calibri" pitchFamily="34" charset="-122"/>
                 <a:cs typeface="Calibri" pitchFamily="34" charset="-120"/>
               </a:rPr>
-              <a:t>VTX Protocol  —  Investor Presentation  —  Junho 2026</a:t>
+              <a:t>TRV Protocol  —  Investor Presentation  —  Junho 2026</a:t>
             </a:r>
             <a:endParaRPr lang="en-US" sz="1400" dirty="0"/>
           </a:p>
@@ -4715,6 +4727,10 @@
             <a:prstDash val="solid"/>
           </a:ln>
         </p:spPr>
+        <p:txBody>
+          <a:bodyPr/>
+          <a:p/>
+        </p:txBody>
       </p:sp>
       <p:sp>
         <p:nvSpPr>
@@ -4747,6 +4763,10 @@
             </a:outerShdw>
           </a:effectLst>
         </p:spPr>
+        <p:txBody>
+          <a:bodyPr/>
+          <a:p/>
+        </p:txBody>
       </p:sp>
       <p:sp>
         <p:nvSpPr>
@@ -4772,6 +4792,10 @@
             <a:prstDash val="solid"/>
           </a:ln>
         </p:spPr>
+        <p:txBody>
+          <a:bodyPr/>
+          <a:p/>
+        </p:txBody>
       </p:sp>
       <p:sp>
         <p:nvSpPr>
@@ -4916,6 +4940,10 @@
             </a:outerShdw>
           </a:effectLst>
         </p:spPr>
+        <p:txBody>
+          <a:bodyPr/>
+          <a:p/>
+        </p:txBody>
       </p:sp>
       <p:sp>
         <p:nvSpPr>
@@ -4941,6 +4969,10 @@
             <a:prstDash val="solid"/>
           </a:ln>
         </p:spPr>
+        <p:txBody>
+          <a:bodyPr/>
+          <a:p/>
+        </p:txBody>
       </p:sp>
       <p:sp>
         <p:nvSpPr>
@@ -5085,6 +5117,10 @@
             </a:outerShdw>
           </a:effectLst>
         </p:spPr>
+        <p:txBody>
+          <a:bodyPr/>
+          <a:p/>
+        </p:txBody>
       </p:sp>
       <p:sp>
         <p:nvSpPr>
@@ -5110,6 +5146,10 @@
             <a:prstDash val="solid"/>
           </a:ln>
         </p:spPr>
+        <p:txBody>
+          <a:bodyPr/>
+          <a:p/>
+        </p:txBody>
       </p:sp>
       <p:sp>
         <p:nvSpPr>
@@ -5254,6 +5294,10 @@
             </a:outerShdw>
           </a:effectLst>
         </p:spPr>
+        <p:txBody>
+          <a:bodyPr/>
+          <a:p/>
+        </p:txBody>
       </p:sp>
       <p:sp>
         <p:nvSpPr>
@@ -5279,6 +5323,10 @@
             <a:prstDash val="solid"/>
           </a:ln>
         </p:spPr>
+        <p:txBody>
+          <a:bodyPr/>
+          <a:p/>
+        </p:txBody>
       </p:sp>
       <p:sp>
         <p:nvSpPr>
@@ -5487,6 +5535,10 @@
             <a:prstDash val="solid"/>
           </a:ln>
         </p:spPr>
+        <p:txBody>
+          <a:bodyPr/>
+          <a:p/>
+        </p:txBody>
       </p:sp>
       <p:sp>
         <p:nvSpPr>
@@ -5551,6 +5603,10 @@
             <a:prstDash val="solid"/>
           </a:ln>
         </p:spPr>
+        <p:txBody>
+          <a:bodyPr/>
+          <a:p/>
+        </p:txBody>
       </p:sp>
       <p:sp>
         <p:nvSpPr>
@@ -5615,6 +5671,10 @@
             <a:prstDash val="solid"/>
           </a:ln>
         </p:spPr>
+        <p:txBody>
+          <a:bodyPr/>
+          <a:p/>
+        </p:txBody>
       </p:sp>
       <p:sp>
         <p:nvSpPr>
@@ -5679,6 +5739,10 @@
             <a:prstDash val="solid"/>
           </a:ln>
         </p:spPr>
+        <p:txBody>
+          <a:bodyPr/>
+          <a:p/>
+        </p:txBody>
       </p:sp>
       <p:sp>
         <p:nvSpPr>
@@ -5743,6 +5807,10 @@
             <a:prstDash val="solid"/>
           </a:ln>
         </p:spPr>
+        <p:txBody>
+          <a:bodyPr/>
+          <a:p/>
+        </p:txBody>
       </p:sp>
       <p:sp>
         <p:nvSpPr>
@@ -5807,6 +5875,10 @@
             <a:prstDash val="solid"/>
           </a:ln>
         </p:spPr>
+        <p:txBody>
+          <a:bodyPr/>
+          <a:p/>
+        </p:txBody>
       </p:sp>
       <p:sp>
         <p:nvSpPr>
@@ -5871,6 +5943,10 @@
             <a:prstDash val="solid"/>
           </a:ln>
         </p:spPr>
+        <p:txBody>
+          <a:bodyPr/>
+          <a:p/>
+        </p:txBody>
       </p:sp>
       <p:sp>
         <p:nvSpPr>
@@ -5935,6 +6011,10 @@
             <a:prstDash val="solid"/>
           </a:ln>
         </p:spPr>
+        <p:txBody>
+          <a:bodyPr/>
+          <a:p/>
+        </p:txBody>
       </p:sp>
       <p:sp>
         <p:nvSpPr>
@@ -5999,6 +6079,10 @@
             <a:prstDash val="solid"/>
           </a:ln>
         </p:spPr>
+        <p:txBody>
+          <a:bodyPr/>
+          <a:p/>
+        </p:txBody>
       </p:sp>
       <p:sp>
         <p:nvSpPr>
@@ -6063,6 +6147,10 @@
             <a:prstDash val="solid"/>
           </a:ln>
         </p:spPr>
+        <p:txBody>
+          <a:bodyPr/>
+          <a:p/>
+        </p:txBody>
       </p:sp>
       <p:sp>
         <p:nvSpPr>
@@ -6205,6 +6293,10 @@
             </a:outerShdw>
           </a:effectLst>
         </p:spPr>
+        <p:txBody>
+          <a:bodyPr/>
+          <a:p/>
+        </p:txBody>
       </p:sp>
       <p:sp>
         <p:nvSpPr>
@@ -6230,6 +6322,10 @@
             <a:prstDash val="solid"/>
           </a:ln>
         </p:spPr>
+        <p:txBody>
+          <a:bodyPr/>
+          <a:p/>
+        </p:txBody>
       </p:sp>
       <p:sp>
         <p:nvSpPr>
@@ -6435,6 +6531,10 @@
             </a:outerShdw>
           </a:effectLst>
         </p:spPr>
+        <p:txBody>
+          <a:bodyPr/>
+          <a:p/>
+        </p:txBody>
       </p:sp>
       <p:sp>
         <p:nvSpPr>
@@ -6460,6 +6560,10 @@
             <a:prstDash val="solid"/>
           </a:ln>
         </p:spPr>
+        <p:txBody>
+          <a:bodyPr/>
+          <a:p/>
+        </p:txBody>
       </p:sp>
       <p:sp>
         <p:nvSpPr>
@@ -6665,6 +6769,10 @@
             </a:outerShdw>
           </a:effectLst>
         </p:spPr>
+        <p:txBody>
+          <a:bodyPr/>
+          <a:p/>
+        </p:txBody>
       </p:sp>
       <p:sp>
         <p:nvSpPr>
@@ -6690,6 +6798,10 @@
             <a:prstDash val="solid"/>
           </a:ln>
         </p:spPr>
+        <p:txBody>
+          <a:bodyPr/>
+          <a:p/>
+        </p:txBody>
       </p:sp>
       <p:sp>
         <p:nvSpPr>
@@ -6895,6 +7007,10 @@
             </a:outerShdw>
           </a:effectLst>
         </p:spPr>
+        <p:txBody>
+          <a:bodyPr/>
+          <a:p/>
+        </p:txBody>
       </p:sp>
       <p:sp>
         <p:nvSpPr>
@@ -6920,6 +7036,10 @@
             <a:prstDash val="solid"/>
           </a:ln>
         </p:spPr>
+        <p:txBody>
+          <a:bodyPr/>
+          <a:p/>
+        </p:txBody>
       </p:sp>
       <p:sp>
         <p:nvSpPr>
@@ -7196,6 +7316,10 @@
             </a:outerShdw>
           </a:effectLst>
         </p:spPr>
+        <p:txBody>
+          <a:bodyPr/>
+          <a:p/>
+        </p:txBody>
       </p:sp>
       <p:sp>
         <p:nvSpPr>
@@ -7260,6 +7384,10 @@
             <a:prstDash val="solid"/>
           </a:ln>
         </p:spPr>
+        <p:txBody>
+          <a:bodyPr/>
+          <a:p/>
+        </p:txBody>
       </p:sp>
       <p:sp>
         <p:nvSpPr>
@@ -7363,6 +7491,10 @@
             <a:prstDash val="solid"/>
           </a:ln>
         </p:spPr>
+        <p:txBody>
+          <a:bodyPr/>
+          <a:p/>
+        </p:txBody>
       </p:sp>
       <p:sp>
         <p:nvSpPr>
@@ -7466,6 +7598,10 @@
             <a:prstDash val="solid"/>
           </a:ln>
         </p:spPr>
+        <p:txBody>
+          <a:bodyPr/>
+          <a:p/>
+        </p:txBody>
       </p:sp>
       <p:sp>
         <p:nvSpPr>
@@ -7569,6 +7705,10 @@
             <a:prstDash val="solid"/>
           </a:ln>
         </p:spPr>
+        <p:txBody>
+          <a:bodyPr/>
+          <a:p/>
+        </p:txBody>
       </p:sp>
       <p:sp>
         <p:nvSpPr>
@@ -7672,6 +7812,10 @@
             <a:prstDash val="solid"/>
           </a:ln>
         </p:spPr>
+        <p:txBody>
+          <a:bodyPr/>
+          <a:p/>
+        </p:txBody>
       </p:sp>
       <p:sp>
         <p:nvSpPr>
@@ -7782,6 +7926,10 @@
             </a:outerShdw>
           </a:effectLst>
         </p:spPr>
+        <p:txBody>
+          <a:bodyPr/>
+          <a:p/>
+        </p:txBody>
       </p:sp>
       <p:sp>
         <p:nvSpPr>
@@ -8270,6 +8418,10 @@
             <a:prstDash val="solid"/>
           </a:ln>
         </p:spPr>
+        <p:txBody>
+          <a:bodyPr/>
+          <a:p/>
+        </p:txBody>
       </p:sp>
       <p:sp>
         <p:nvSpPr>
@@ -8297,6 +8449,10 @@
             <a:prstDash val="solid"/>
           </a:ln>
         </p:spPr>
+        <p:txBody>
+          <a:bodyPr/>
+          <a:p/>
+        </p:txBody>
       </p:sp>
       <p:sp>
         <p:nvSpPr>
@@ -8370,7 +8526,7 @@
                 <a:ea typeface="Georgia" pitchFamily="34" charset="-122"/>
                 <a:cs typeface="Georgia" pitchFamily="34" charset="-120"/>
               </a:rPr>
-              <a:t>Vortex Protocol</a:t>
+              <a:t>Traverse Protocol</a:t>
             </a:r>
             <a:endParaRPr lang="en-US" sz="2200" dirty="0"/>
           </a:p>
@@ -8409,7 +8565,7 @@
                 <a:ea typeface="Calibri" pitchFamily="34" charset="-122"/>
                 <a:cs typeface="Calibri" pitchFamily="34" charset="-120"/>
               </a:rPr>
-              <a:t>vtxprotocol.io  |  hello@vtxprotocol.io</a:t>
+              <a:t>traverseprotocol.io  |  hello@traverseprotocol.io</a:t>
             </a:r>
             <a:endParaRPr lang="en-US" sz="1400" dirty="0"/>
           </a:p>
@@ -8519,7 +8675,7 @@
                 <a:ea typeface="Calibri" pitchFamily="34" charset="-122"/>
                 <a:cs typeface="Calibri" pitchFamily="34" charset="-120"/>
               </a:rPr>
-              <a:t>Este material é para fins informativos exclusivamente e não constitui oferta de valores mobiliários, conselho de investimento, financeiro ou jurídico. Tokens VTX representam direitos de utilidade e governança dentro do protocolo Vortex. Investimentos em ativos digitais envolvem riscos substanciais incluindo perda total do capital investido. Projeções e estimativas são ilustrativas e não garantem qualquer retorno. Consulte assessores jurídicos e financeiros qualificados antes de tomar qualquer decisão de investimento. Este documento não foi registrado em nenhuma autoridade regulatória.</a:t>
+              <a:t>Este material é para fins informativos exclusivamente e não constitui oferta de valores mobiliários, conselho de investimento, financeiro ou jurídico. Tokens TRV representam direitos de utilidade e governança dentro do protocolo Traverse. Investimentos em ativos digitais envolvem riscos substanciais incluindo perda total do capital investido. Projeções e estimativas são ilustrativas e não garantem qualquer retorno. Consulte assessores jurídicos e financeiros qualificados antes de tomar qualquer decisão de investimento. Este documento não foi registrado em nenhuma autoridade regulatória.</a:t>
             </a:r>
             <a:endParaRPr lang="en-US" sz="1100" dirty="0"/>
           </a:p>
@@ -8627,6 +8783,10 @@
             </a:outerShdw>
           </a:effectLst>
         </p:spPr>
+        <p:txBody>
+          <a:bodyPr/>
+          <a:p/>
+        </p:txBody>
       </p:sp>
       <p:sp>
         <p:nvSpPr>
@@ -8652,6 +8812,10 @@
             <a:prstDash val="solid"/>
           </a:ln>
         </p:spPr>
+        <p:txBody>
+          <a:bodyPr/>
+          <a:p/>
+        </p:txBody>
       </p:sp>
       <p:sp>
         <p:nvSpPr>
@@ -8779,6 +8943,10 @@
             </a:outerShdw>
           </a:effectLst>
         </p:spPr>
+        <p:txBody>
+          <a:bodyPr/>
+          <a:p/>
+        </p:txBody>
       </p:sp>
       <p:sp>
         <p:nvSpPr>
@@ -8804,6 +8972,10 @@
             <a:prstDash val="solid"/>
           </a:ln>
         </p:spPr>
+        <p:txBody>
+          <a:bodyPr/>
+          <a:p/>
+        </p:txBody>
       </p:sp>
       <p:sp>
         <p:nvSpPr>
@@ -8931,6 +9103,10 @@
             </a:outerShdw>
           </a:effectLst>
         </p:spPr>
+        <p:txBody>
+          <a:bodyPr/>
+          <a:p/>
+        </p:txBody>
       </p:sp>
       <p:sp>
         <p:nvSpPr>
@@ -8956,6 +9132,10 @@
             <a:prstDash val="solid"/>
           </a:ln>
         </p:spPr>
+        <p:txBody>
+          <a:bodyPr/>
+          <a:p/>
+        </p:txBody>
       </p:sp>
       <p:sp>
         <p:nvSpPr>
@@ -9193,6 +9373,10 @@
             </a:outerShdw>
           </a:effectLst>
         </p:spPr>
+        <p:txBody>
+          <a:bodyPr/>
+          <a:p/>
+        </p:txBody>
       </p:sp>
       <p:sp>
         <p:nvSpPr>
@@ -9303,6 +9487,10 @@
             </a:outerShdw>
           </a:effectLst>
         </p:spPr>
+        <p:txBody>
+          <a:bodyPr/>
+          <a:p/>
+        </p:txBody>
       </p:sp>
       <p:sp>
         <p:nvSpPr>
@@ -9413,6 +9601,10 @@
             </a:outerShdw>
           </a:effectLst>
         </p:spPr>
+        <p:txBody>
+          <a:bodyPr/>
+          <a:p/>
+        </p:txBody>
       </p:sp>
       <p:sp>
         <p:nvSpPr>
@@ -9596,7 +9788,7 @@
                 <a:ea typeface="Georgia" pitchFamily="34" charset="-122"/>
                 <a:cs typeface="Georgia" pitchFamily="34" charset="-120"/>
               </a:rPr>
-              <a:t>Vortex: Um Fluxo. Qualquer Chain.</a:t>
+              <a:t>Traverse: Um Fluxo. Qualquer Chain.</a:t>
             </a:r>
             <a:endParaRPr lang="en-US" sz="3000" dirty="0"/>
           </a:p>
@@ -9626,6 +9818,10 @@
             <a:prstDash val="solid"/>
           </a:ln>
         </p:spPr>
+        <p:txBody>
+          <a:bodyPr/>
+          <a:p/>
+        </p:txBody>
       </p:sp>
       <p:sp>
         <p:nvSpPr>
@@ -9651,6 +9847,10 @@
             <a:prstDash val="solid"/>
           </a:ln>
         </p:spPr>
+        <p:txBody>
+          <a:bodyPr/>
+          <a:p/>
+        </p:txBody>
       </p:sp>
       <p:sp>
         <p:nvSpPr>
@@ -9754,6 +9954,10 @@
             <a:prstDash val="solid"/>
           </a:ln>
         </p:spPr>
+        <p:txBody>
+          <a:bodyPr/>
+          <a:p/>
+        </p:txBody>
       </p:sp>
       <p:sp>
         <p:nvSpPr>
@@ -9779,6 +9983,10 @@
             <a:prstDash val="solid"/>
           </a:ln>
         </p:spPr>
+        <p:txBody>
+          <a:bodyPr/>
+          <a:p/>
+        </p:txBody>
       </p:sp>
       <p:sp>
         <p:nvSpPr>
@@ -9882,6 +10090,10 @@
             <a:prstDash val="solid"/>
           </a:ln>
         </p:spPr>
+        <p:txBody>
+          <a:bodyPr/>
+          <a:p/>
+        </p:txBody>
       </p:sp>
       <p:sp>
         <p:nvSpPr>
@@ -9907,6 +10119,10 @@
             <a:prstDash val="solid"/>
           </a:ln>
         </p:spPr>
+        <p:txBody>
+          <a:bodyPr/>
+          <a:p/>
+        </p:txBody>
       </p:sp>
       <p:sp>
         <p:nvSpPr>
@@ -10010,6 +10226,10 @@
             <a:prstDash val="solid"/>
           </a:ln>
         </p:spPr>
+        <p:txBody>
+          <a:bodyPr/>
+          <a:p/>
+        </p:txBody>
       </p:sp>
       <p:sp>
         <p:nvSpPr>
@@ -10035,6 +10255,10 @@
             <a:prstDash val="solid"/>
           </a:ln>
         </p:spPr>
+        <p:txBody>
+          <a:bodyPr/>
+          <a:p/>
+        </p:txBody>
       </p:sp>
       <p:sp>
         <p:nvSpPr>
@@ -10216,6 +10440,10 @@
             </a:outerShdw>
           </a:effectLst>
         </p:spPr>
+        <p:txBody>
+          <a:bodyPr/>
+          <a:p/>
+        </p:txBody>
       </p:sp>
       <p:sp>
         <p:nvSpPr>
@@ -10370,6 +10598,10 @@
             <a:prstDash val="solid"/>
           </a:ln>
         </p:spPr>
+        <p:txBody>
+          <a:bodyPr/>
+          <a:p/>
+        </p:txBody>
       </p:sp>
       <p:sp>
         <p:nvSpPr>
@@ -10402,6 +10634,10 @@
             </a:outerShdw>
           </a:effectLst>
         </p:spPr>
+        <p:txBody>
+          <a:bodyPr/>
+          <a:p/>
+        </p:txBody>
       </p:sp>
       <p:sp>
         <p:nvSpPr>
@@ -10539,6 +10775,10 @@
             <a:prstDash val="solid"/>
           </a:ln>
         </p:spPr>
+        <p:txBody>
+          <a:bodyPr/>
+          <a:p/>
+        </p:txBody>
       </p:sp>
       <p:sp>
         <p:nvSpPr>
@@ -10571,6 +10811,10 @@
             </a:outerShdw>
           </a:effectLst>
         </p:spPr>
+        <p:txBody>
+          <a:bodyPr/>
+          <a:p/>
+        </p:txBody>
       </p:sp>
       <p:sp>
         <p:nvSpPr>
@@ -10708,6 +10952,10 @@
             <a:prstDash val="solid"/>
           </a:ln>
         </p:spPr>
+        <p:txBody>
+          <a:bodyPr/>
+          <a:p/>
+        </p:txBody>
       </p:sp>
       <p:sp>
         <p:nvSpPr>
@@ -10740,6 +10988,10 @@
             </a:outerShdw>
           </a:effectLst>
         </p:spPr>
+        <p:txBody>
+          <a:bodyPr/>
+          <a:p/>
+        </p:txBody>
       </p:sp>
       <p:sp>
         <p:nvSpPr>
@@ -10869,7 +11121,7 @@
                 <a:ea typeface="Calibri" pitchFamily="34" charset="-122"/>
                 <a:cs typeface="Calibri" pitchFamily="34" charset="-120"/>
               </a:rPr>
-              <a:t>Solvers precisam de stake em VTX. Má execução = slashing.</a:t>
+              <a:t>Solvers precisam de stake em TRV. Má execução = slashing.</a:t>
             </a:r>
             <a:endParaRPr lang="en-US" sz="1300" dirty="0"/>
           </a:p>
@@ -11025,7 +11277,7 @@
                 <a:ea typeface="Calibri" pitchFamily="34" charset="-122"/>
                 <a:cs typeface="Calibri" pitchFamily="34" charset="-120"/>
               </a:rPr>
-              <a:t>Solver Registry: Registro com stake mínimo (10k VTX)</a:t>
+              <a:t>Solver Registry: Registro com stake mínimo (10k TRV)</a:t>
             </a:r>
             <a:endParaRPr lang="en-US" sz="1300" dirty="0"/>
           </a:p>
@@ -11101,6 +11353,10 @@
             </a:outerShdw>
           </a:effectLst>
         </p:spPr>
+        <p:txBody>
+          <a:bodyPr/>
+          <a:p/>
+        </p:txBody>
       </p:sp>
       <p:sp>
         <p:nvSpPr>
@@ -11135,7 +11391,7 @@
                 <a:ea typeface="Consolas" pitchFamily="34" charset="-122"/>
                 <a:cs typeface="Consolas" pitchFamily="34" charset="-120"/>
               </a:rPr>
-              <a:t>VortexRouter.sol</a:t>
+              <a:t>TraverseRouter.sol</a:t>
             </a:r>
             <a:endParaRPr lang="en-US" sz="1400" dirty="0"/>
           </a:p>
@@ -11211,6 +11467,10 @@
             </a:outerShdw>
           </a:effectLst>
         </p:spPr>
+        <p:txBody>
+          <a:bodyPr/>
+          <a:p/>
+        </p:txBody>
       </p:sp>
       <p:sp>
         <p:nvSpPr>
@@ -11245,7 +11505,7 @@
                 <a:ea typeface="Consolas" pitchFamily="34" charset="-122"/>
                 <a:cs typeface="Consolas" pitchFamily="34" charset="-120"/>
               </a:rPr>
-              <a:t>VortexStaking.sol</a:t>
+              <a:t>TraverseStaking.sol</a:t>
             </a:r>
             <a:endParaRPr lang="en-US" sz="1400" dirty="0"/>
           </a:p>
@@ -11321,6 +11581,10 @@
             </a:outerShdw>
           </a:effectLst>
         </p:spPr>
+        <p:txBody>
+          <a:bodyPr/>
+          <a:p/>
+        </p:txBody>
       </p:sp>
       <p:sp>
         <p:nvSpPr>
@@ -11355,7 +11619,7 @@
                 <a:ea typeface="Consolas" pitchFamily="34" charset="-122"/>
                 <a:cs typeface="Consolas" pitchFamily="34" charset="-120"/>
               </a:rPr>
-              <a:t>VortexGovernor.sol</a:t>
+              <a:t>TraverseGovernor.sol</a:t>
             </a:r>
             <a:endParaRPr lang="en-US" sz="1400" dirty="0"/>
           </a:p>
@@ -11465,7 +11729,7 @@
                 <a:ea typeface="Georgia" pitchFamily="34" charset="-122"/>
                 <a:cs typeface="Georgia" pitchFamily="34" charset="-120"/>
               </a:rPr>
-              <a:t>Por Que Agora? Por Que Vortex?</a:t>
+              <a:t>Por Que Agora? Por Que Traverse?</a:t>
             </a:r>
             <a:endParaRPr lang="en-US" sz="3200" dirty="0"/>
           </a:p>
@@ -11587,7 +11851,7 @@
                           <a:ea typeface="Calibri" pitchFamily="34" charset="-122"/>
                           <a:cs typeface="Calibri" pitchFamily="34" charset="-120"/>
                         </a:rPr>
-                        <a:t>Vortex</a:t>
+                        <a:t>Traverse</a:t>
                       </a:r>
                       <a:endParaRPr lang="en-US" sz="1200" dirty="0">
                         <a:latin typeface="Calibri" charset="0"/>
@@ -13569,7 +13833,7 @@
                           <a:ea typeface="Calibri" pitchFamily="34" charset="-122"/>
                           <a:cs typeface="Calibri" pitchFamily="34" charset="-120"/>
                         </a:rPr>
-                        <a:t>Revenue sharing VTX</a:t>
+                        <a:t>Revenue sharing TRV</a:t>
                       </a:r>
                       <a:endParaRPr lang="en-US" sz="1200" dirty="0">
                         <a:latin typeface="Calibri" charset="0"/>
@@ -14030,7 +14294,7 @@
                 <a:ea typeface="Georgia" pitchFamily="34" charset="-122"/>
                 <a:cs typeface="Georgia" pitchFamily="34" charset="-120"/>
               </a:rPr>
-              <a:t>VTX — Utilidade Real, Não Decoração</a:t>
+              <a:t>TRV — Utilidade Real, Não Decoração</a:t>
             </a:r>
             <a:endParaRPr lang="en-US" sz="2800" dirty="0"/>
           </a:p>
@@ -14067,6 +14331,10 @@
             </a:outerShdw>
           </a:effectLst>
         </p:spPr>
+        <p:txBody>
+          <a:bodyPr/>
+          <a:p/>
+        </p:txBody>
       </p:sp>
       <p:sp>
         <p:nvSpPr>
@@ -14092,6 +14360,10 @@
             <a:prstDash val="solid"/>
           </a:ln>
         </p:spPr>
+        <p:txBody>
+          <a:bodyPr/>
+          <a:p/>
+        </p:txBody>
       </p:sp>
       <p:sp>
         <p:nvSpPr>
@@ -14165,7 +14437,7 @@
                 <a:ea typeface="Calibri" pitchFamily="34" charset="-122"/>
                 <a:cs typeface="Calibri" pitchFamily="34" charset="-120"/>
               </a:rPr>
-              <a:t>10k VTX mínimo</a:t>
+              <a:t>10k TRV mínimo</a:t>
             </a:r>
             <a:endParaRPr lang="en-US" sz="1200" dirty="0"/>
           </a:p>
@@ -14253,6 +14525,10 @@
             </a:outerShdw>
           </a:effectLst>
         </p:spPr>
+        <p:txBody>
+          <a:bodyPr/>
+          <a:p/>
+        </p:txBody>
       </p:sp>
       <p:sp>
         <p:nvSpPr>
@@ -14278,6 +14554,10 @@
             <a:prstDash val="solid"/>
           </a:ln>
         </p:spPr>
+        <p:txBody>
+          <a:bodyPr/>
+          <a:p/>
+        </p:txBody>
       </p:sp>
       <p:sp>
         <p:nvSpPr>
@@ -14351,7 +14631,7 @@
                 <a:ea typeface="Calibri" pitchFamily="34" charset="-122"/>
                 <a:cs typeface="Calibri" pitchFamily="34" charset="-120"/>
               </a:rPr>
-              <a:t>1 VTX = 1 voto</a:t>
+              <a:t>1 TRV = 1 voto</a:t>
             </a:r>
             <a:endParaRPr lang="en-US" sz="1200" dirty="0"/>
           </a:p>
@@ -14439,6 +14719,10 @@
             </a:outerShdw>
           </a:effectLst>
         </p:spPr>
+        <p:txBody>
+          <a:bodyPr/>
+          <a:p/>
+        </p:txBody>
       </p:sp>
       <p:sp>
         <p:nvSpPr>
@@ -14464,6 +14748,10 @@
             <a:prstDash val="solid"/>
           </a:ln>
         </p:spPr>
+        <p:txBody>
+          <a:bodyPr/>
+          <a:p/>
+        </p:txBody>
       </p:sp>
       <p:sp>
         <p:nvSpPr>
@@ -14625,6 +14913,10 @@
             </a:outerShdw>
           </a:effectLst>
         </p:spPr>
+        <p:txBody>
+          <a:bodyPr/>
+          <a:p/>
+        </p:txBody>
       </p:sp>
       <p:sp>
         <p:nvSpPr>
@@ -14650,6 +14942,10 @@
             <a:prstDash val="solid"/>
           </a:ln>
         </p:spPr>
+        <p:txBody>
+          <a:bodyPr/>
+          <a:p/>
+        </p:txBody>
       </p:sp>
       <p:sp>
         <p:nvSpPr>
@@ -14845,7 +15141,7 @@
                 <a:ea typeface="Georgia" pitchFamily="34" charset="-122"/>
                 <a:cs typeface="Georgia" pitchFamily="34" charset="-120"/>
               </a:rPr>
-              <a:t>Distribuição do Supply — 1 Bilhão VTX</a:t>
+              <a:t>Distribuição do Supply — 1 Bilhão TRV</a:t>
             </a:r>
             <a:endParaRPr lang="en-US" sz="3200" dirty="0"/>
           </a:p>
@@ -14898,6 +15194,10 @@
             </a:outerShdw>
           </a:effectLst>
         </p:spPr>
+        <p:txBody>
+          <a:bodyPr/>
+          <a:p/>
+        </p:txBody>
       </p:sp>
       <p:sp>
         <p:nvSpPr>
@@ -14932,7 +15232,7 @@
                 <a:ea typeface="Calibri" pitchFamily="34" charset="-122"/>
                 <a:cs typeface="Calibri" pitchFamily="34" charset="-120"/>
               </a:rPr>
-              <a:t>Supply fixo: 1B VTX, sem mint</a:t>
+              <a:t>Supply fixo: 1B TRV, sem mint</a:t>
             </a:r>
             <a:endParaRPr lang="en-US" sz="1300" dirty="0"/>
           </a:p>
@@ -14969,6 +15269,10 @@
             </a:outerShdw>
           </a:effectLst>
         </p:spPr>
+        <p:txBody>
+          <a:bodyPr/>
+          <a:p/>
+        </p:txBody>
       </p:sp>
       <p:sp>
         <p:nvSpPr>
@@ -15040,6 +15344,10 @@
             </a:outerShdw>
           </a:effectLst>
         </p:spPr>
+        <p:txBody>
+          <a:bodyPr/>
+          <a:p/>
+        </p:txBody>
       </p:sp>
       <p:sp>
         <p:nvSpPr>

</xml_diff>